<commit_message>
docs: add PBL Final Documentation report (.docx) and update Review PPTs with exact team and faculty details
</commit_message>
<xml_diff>
--- a/PPT/Review 2.pptx
+++ b/PPT/Review 2.pptx
@@ -1611,6 +1611,10 @@
             <a:prstDash val="solid"/>
           </a:ln>
         </p:spPr>
+        <p:txBody>
+          <a:bodyPr/>
+          <a:p/>
+        </p:txBody>
       </p:sp>
       <p:sp>
         <p:nvSpPr>
@@ -1642,6 +1646,10 @@
             <a:prstDash val="solid"/>
           </a:ln>
         </p:spPr>
+        <p:txBody>
+          <a:bodyPr/>
+          <a:p/>
+        </p:txBody>
       </p:sp>
       <p:sp>
         <p:nvSpPr>
@@ -1900,12 +1908,7 @@
               </a:defRPr>
             </a:pPr>
             <a:r>
-              <a:rPr sz="1200" b="0">
-                <a:solidFill>
-                  <a:srgbClr val="DCE9FF"/>
-                </a:solidFill>
-              </a:rPr>
-              <a:t>Supervisor: __________________</a:t>
+              <a:t>Supervisor: Dr. M. Saidireddy</a:t>
             </a:r>
           </a:p>
         </p:txBody>
@@ -2044,6 +2047,10 @@
             <a:prstDash val="solid"/>
           </a:ln>
         </p:spPr>
+        <p:txBody>
+          <a:bodyPr/>
+          <a:p/>
+        </p:txBody>
       </p:sp>
       <p:sp>
         <p:nvSpPr>
@@ -2077,6 +2084,10 @@
             <a:prstDash val="solid"/>
           </a:ln>
         </p:spPr>
+        <p:txBody>
+          <a:bodyPr/>
+          <a:p/>
+        </p:txBody>
       </p:sp>
       <p:sp>
         <p:nvSpPr>
@@ -2262,6 +2273,10 @@
             <a:prstDash val="solid"/>
           </a:ln>
         </p:spPr>
+        <p:txBody>
+          <a:bodyPr/>
+          <a:p/>
+        </p:txBody>
       </p:sp>
       <p:sp>
         <p:nvSpPr>
@@ -2295,6 +2310,10 @@
             <a:prstDash val="solid"/>
           </a:ln>
         </p:spPr>
+        <p:txBody>
+          <a:bodyPr/>
+          <a:p/>
+        </p:txBody>
       </p:sp>
       <p:sp>
         <p:nvSpPr>
@@ -2480,6 +2499,10 @@
             <a:prstDash val="solid"/>
           </a:ln>
         </p:spPr>
+        <p:txBody>
+          <a:bodyPr/>
+          <a:p/>
+        </p:txBody>
       </p:sp>
       <p:sp>
         <p:nvSpPr>
@@ -2513,6 +2536,10 @@
             <a:prstDash val="solid"/>
           </a:ln>
         </p:spPr>
+        <p:txBody>
+          <a:bodyPr/>
+          <a:p/>
+        </p:txBody>
       </p:sp>
       <p:sp>
         <p:nvSpPr>
@@ -2698,6 +2725,10 @@
             <a:prstDash val="solid"/>
           </a:ln>
         </p:spPr>
+        <p:txBody>
+          <a:bodyPr/>
+          <a:p/>
+        </p:txBody>
       </p:sp>
       <p:sp>
         <p:nvSpPr>
@@ -2731,6 +2762,10 @@
             <a:prstDash val="solid"/>
           </a:ln>
         </p:spPr>
+        <p:txBody>
+          <a:bodyPr/>
+          <a:p/>
+        </p:txBody>
       </p:sp>
       <p:sp>
         <p:nvSpPr>
@@ -2916,6 +2951,10 @@
             <a:prstDash val="solid"/>
           </a:ln>
         </p:spPr>
+        <p:txBody>
+          <a:bodyPr/>
+          <a:p/>
+        </p:txBody>
       </p:sp>
       <p:sp>
         <p:nvSpPr>
@@ -2949,6 +2988,10 @@
             <a:prstDash val="solid"/>
           </a:ln>
         </p:spPr>
+        <p:txBody>
+          <a:bodyPr/>
+          <a:p/>
+        </p:txBody>
       </p:sp>
       <p:sp>
         <p:nvSpPr>
@@ -3468,6 +3511,10 @@
             <a:prstDash val="solid"/>
           </a:ln>
         </p:spPr>
+        <p:txBody>
+          <a:bodyPr/>
+          <a:p/>
+        </p:txBody>
       </p:sp>
       <p:sp>
         <p:nvSpPr>
@@ -3551,6 +3598,10 @@
             <a:prstDash val="solid"/>
           </a:ln>
         </p:spPr>
+        <p:txBody>
+          <a:bodyPr/>
+          <a:p/>
+        </p:txBody>
       </p:sp>
       <p:sp>
         <p:nvSpPr>
@@ -3634,6 +3685,10 @@
             <a:prstDash val="solid"/>
           </a:ln>
         </p:spPr>
+        <p:txBody>
+          <a:bodyPr/>
+          <a:p/>
+        </p:txBody>
       </p:sp>
       <p:sp>
         <p:nvSpPr>
@@ -3717,6 +3772,10 @@
             <a:prstDash val="solid"/>
           </a:ln>
         </p:spPr>
+        <p:txBody>
+          <a:bodyPr/>
+          <a:p/>
+        </p:txBody>
       </p:sp>
       <p:sp>
         <p:nvSpPr>
@@ -3800,6 +3859,10 @@
             <a:prstDash val="solid"/>
           </a:ln>
         </p:spPr>
+        <p:txBody>
+          <a:bodyPr/>
+          <a:p/>
+        </p:txBody>
       </p:sp>
       <p:sp>
         <p:nvSpPr>
@@ -3883,6 +3946,10 @@
             <a:prstDash val="solid"/>
           </a:ln>
         </p:spPr>
+        <p:txBody>
+          <a:bodyPr/>
+          <a:p/>
+        </p:txBody>
       </p:sp>
       <p:sp>
         <p:nvSpPr>
@@ -4018,6 +4085,10 @@
             <a:prstDash val="solid"/>
           </a:ln>
         </p:spPr>
+        <p:txBody>
+          <a:bodyPr/>
+          <a:p/>
+        </p:txBody>
       </p:sp>
       <p:sp>
         <p:nvSpPr>
@@ -4051,6 +4122,10 @@
             <a:prstDash val="solid"/>
           </a:ln>
         </p:spPr>
+        <p:txBody>
+          <a:bodyPr/>
+          <a:p/>
+        </p:txBody>
       </p:sp>
       <p:sp>
         <p:nvSpPr>
@@ -4203,6 +4278,10 @@
             <a:prstDash val="solid"/>
           </a:ln>
         </p:spPr>
+        <p:txBody>
+          <a:bodyPr/>
+          <a:p/>
+        </p:txBody>
       </p:sp>
       <p:sp>
         <p:nvSpPr>
@@ -4236,6 +4315,10 @@
             <a:prstDash val="solid"/>
           </a:ln>
         </p:spPr>
+        <p:txBody>
+          <a:bodyPr/>
+          <a:p/>
+        </p:txBody>
       </p:sp>
       <p:sp>
         <p:nvSpPr>
@@ -4371,6 +4454,10 @@
             <a:prstDash val="solid"/>
           </a:ln>
         </p:spPr>
+        <p:txBody>
+          <a:bodyPr/>
+          <a:p/>
+        </p:txBody>
       </p:sp>
       <p:sp>
         <p:nvSpPr>
@@ -4404,6 +4491,10 @@
             <a:prstDash val="solid"/>
           </a:ln>
         </p:spPr>
+        <p:txBody>
+          <a:bodyPr/>
+          <a:p/>
+        </p:txBody>
       </p:sp>
       <p:sp>
         <p:nvSpPr>
@@ -4556,6 +4647,10 @@
             <a:prstDash val="solid"/>
           </a:ln>
         </p:spPr>
+        <p:txBody>
+          <a:bodyPr/>
+          <a:p/>
+        </p:txBody>
       </p:sp>
       <p:sp>
         <p:nvSpPr>
@@ -4589,6 +4684,10 @@
             <a:prstDash val="solid"/>
           </a:ln>
         </p:spPr>
+        <p:txBody>
+          <a:bodyPr/>
+          <a:p/>
+        </p:txBody>
       </p:sp>
       <p:sp>
         <p:nvSpPr>
@@ -4741,6 +4840,10 @@
             <a:prstDash val="solid"/>
           </a:ln>
         </p:spPr>
+        <p:txBody>
+          <a:bodyPr/>
+          <a:p/>
+        </p:txBody>
       </p:sp>
       <p:sp>
         <p:nvSpPr>
@@ -4774,6 +4877,10 @@
             <a:prstDash val="solid"/>
           </a:ln>
         </p:spPr>
+        <p:txBody>
+          <a:bodyPr/>
+          <a:p/>
+        </p:txBody>
       </p:sp>
       <p:sp>
         <p:nvSpPr>
@@ -4926,6 +5033,10 @@
             <a:prstDash val="solid"/>
           </a:ln>
         </p:spPr>
+        <p:txBody>
+          <a:bodyPr/>
+          <a:p/>
+        </p:txBody>
       </p:sp>
       <p:sp>
         <p:nvSpPr>
@@ -4959,6 +5070,10 @@
             <a:prstDash val="solid"/>
           </a:ln>
         </p:spPr>
+        <p:txBody>
+          <a:bodyPr/>
+          <a:p/>
+        </p:txBody>
       </p:sp>
       <p:sp>
         <p:nvSpPr>
@@ -5061,6 +5176,10 @@
             <a:prstDash val="solid"/>
           </a:ln>
         </p:spPr>
+        <p:txBody>
+          <a:bodyPr/>
+          <a:p/>
+        </p:txBody>
       </p:sp>
       <p:sp>
         <p:nvSpPr>
@@ -6030,6 +6149,10 @@
             <a:prstDash val="solid"/>
           </a:ln>
         </p:spPr>
+        <p:txBody>
+          <a:bodyPr/>
+          <a:p/>
+        </p:txBody>
       </p:sp>
       <p:sp>
         <p:nvSpPr>
@@ -6061,6 +6184,10 @@
             <a:prstDash val="solid"/>
           </a:ln>
         </p:spPr>
+        <p:txBody>
+          <a:bodyPr/>
+          <a:p/>
+        </p:txBody>
       </p:sp>
       <p:sp>
         <p:nvSpPr>
@@ -6142,6 +6269,10 @@
             <a:prstDash val="solid"/>
           </a:ln>
         </p:spPr>
+        <p:txBody>
+          <a:bodyPr/>
+          <a:p/>
+        </p:txBody>
       </p:sp>
       <p:sp>
         <p:nvSpPr>
@@ -6223,6 +6354,10 @@
             <a:prstDash val="solid"/>
           </a:ln>
         </p:spPr>
+        <p:txBody>
+          <a:bodyPr/>
+          <a:p/>
+        </p:txBody>
       </p:sp>
       <p:sp>
         <p:nvSpPr>
@@ -6304,6 +6439,10 @@
             <a:prstDash val="solid"/>
           </a:ln>
         </p:spPr>
+        <p:txBody>
+          <a:bodyPr/>
+          <a:p/>
+        </p:txBody>
       </p:sp>
       <p:sp>
         <p:nvSpPr>
@@ -6385,6 +6524,10 @@
             <a:prstDash val="solid"/>
           </a:ln>
         </p:spPr>
+        <p:txBody>
+          <a:bodyPr/>
+          <a:p/>
+        </p:txBody>
       </p:sp>
       <p:sp>
         <p:nvSpPr>
@@ -6468,6 +6611,10 @@
             <a:prstDash val="solid"/>
           </a:ln>
         </p:spPr>
+        <p:txBody>
+          <a:bodyPr/>
+          <a:p/>
+        </p:txBody>
       </p:sp>
       <p:sp>
         <p:nvSpPr>
@@ -6568,6 +6715,10 @@
             <a:prstDash val="solid"/>
           </a:ln>
         </p:spPr>
+        <p:txBody>
+          <a:bodyPr/>
+          <a:p/>
+        </p:txBody>
       </p:sp>
       <p:sp>
         <p:nvSpPr>
@@ -6668,6 +6819,10 @@
             <a:prstDash val="solid"/>
           </a:ln>
         </p:spPr>
+        <p:txBody>
+          <a:bodyPr/>
+          <a:p/>
+        </p:txBody>
       </p:sp>
       <p:sp>
         <p:nvSpPr>
@@ -6768,6 +6923,10 @@
             <a:prstDash val="solid"/>
           </a:ln>
         </p:spPr>
+        <p:txBody>
+          <a:bodyPr/>
+          <a:p/>
+        </p:txBody>
       </p:sp>
       <p:sp>
         <p:nvSpPr>
@@ -6851,6 +7010,10 @@
             <a:prstDash val="solid"/>
           </a:ln>
         </p:spPr>
+        <p:txBody>
+          <a:bodyPr/>
+          <a:p/>
+        </p:txBody>
       </p:sp>
       <p:sp>
         <p:nvSpPr>
@@ -6934,6 +7097,10 @@
             <a:prstDash val="solid"/>
           </a:ln>
         </p:spPr>
+        <p:txBody>
+          <a:bodyPr/>
+          <a:p/>
+        </p:txBody>
       </p:sp>
       <p:sp>
         <p:nvSpPr>
@@ -7034,6 +7201,10 @@
             <a:prstDash val="solid"/>
           </a:ln>
         </p:spPr>
+        <p:txBody>
+          <a:bodyPr/>
+          <a:p/>
+        </p:txBody>
       </p:sp>
       <p:sp>
         <p:nvSpPr>
@@ -7134,6 +7305,10 @@
             <a:prstDash val="solid"/>
           </a:ln>
         </p:spPr>
+        <p:txBody>
+          <a:bodyPr/>
+          <a:p/>
+        </p:txBody>
       </p:sp>
       <p:sp>
         <p:nvSpPr>
@@ -7234,6 +7409,10 @@
             <a:prstDash val="solid"/>
           </a:ln>
         </p:spPr>
+        <p:txBody>
+          <a:bodyPr/>
+          <a:p/>
+        </p:txBody>
       </p:sp>
       <p:sp>
         <p:nvSpPr>
@@ -7317,6 +7496,10 @@
             <a:prstDash val="solid"/>
           </a:ln>
         </p:spPr>
+        <p:txBody>
+          <a:bodyPr/>
+          <a:p/>
+        </p:txBody>
       </p:sp>
       <p:sp>
         <p:nvSpPr>
@@ -7400,6 +7583,10 @@
             <a:prstDash val="solid"/>
           </a:ln>
         </p:spPr>
+        <p:txBody>
+          <a:bodyPr/>
+          <a:p/>
+        </p:txBody>
       </p:sp>
       <p:sp>
         <p:nvSpPr>
@@ -7500,6 +7687,10 @@
             <a:prstDash val="solid"/>
           </a:ln>
         </p:spPr>
+        <p:txBody>
+          <a:bodyPr/>
+          <a:p/>
+        </p:txBody>
       </p:sp>
       <p:sp>
         <p:nvSpPr>
@@ -7600,6 +7791,10 @@
             <a:prstDash val="solid"/>
           </a:ln>
         </p:spPr>
+        <p:txBody>
+          <a:bodyPr/>
+          <a:p/>
+        </p:txBody>
       </p:sp>
       <p:sp>
         <p:nvSpPr>
@@ -7700,6 +7895,10 @@
             <a:prstDash val="solid"/>
           </a:ln>
         </p:spPr>
+        <p:txBody>
+          <a:bodyPr/>
+          <a:p/>
+        </p:txBody>
       </p:sp>
       <p:sp>
         <p:nvSpPr>
@@ -7783,6 +7982,10 @@
             <a:prstDash val="solid"/>
           </a:ln>
         </p:spPr>
+        <p:txBody>
+          <a:bodyPr/>
+          <a:p/>
+        </p:txBody>
       </p:sp>
       <p:sp>
         <p:nvSpPr>
@@ -7866,6 +8069,10 @@
             <a:prstDash val="solid"/>
           </a:ln>
         </p:spPr>
+        <p:txBody>
+          <a:bodyPr/>
+          <a:p/>
+        </p:txBody>
       </p:sp>
       <p:sp>
         <p:nvSpPr>
@@ -7966,6 +8173,10 @@
             <a:prstDash val="solid"/>
           </a:ln>
         </p:spPr>
+        <p:txBody>
+          <a:bodyPr/>
+          <a:p/>
+        </p:txBody>
       </p:sp>
       <p:sp>
         <p:nvSpPr>
@@ -8066,6 +8277,10 @@
             <a:prstDash val="solid"/>
           </a:ln>
         </p:spPr>
+        <p:txBody>
+          <a:bodyPr/>
+          <a:p/>
+        </p:txBody>
       </p:sp>
       <p:sp>
         <p:nvSpPr>
@@ -8166,6 +8381,10 @@
             <a:prstDash val="solid"/>
           </a:ln>
         </p:spPr>
+        <p:txBody>
+          <a:bodyPr/>
+          <a:p/>
+        </p:txBody>
       </p:sp>
       <p:sp>
         <p:nvSpPr>
@@ -8249,6 +8468,10 @@
             <a:prstDash val="solid"/>
           </a:ln>
         </p:spPr>
+        <p:txBody>
+          <a:bodyPr/>
+          <a:p/>
+        </p:txBody>
       </p:sp>
       <p:sp>
         <p:nvSpPr>
@@ -8332,6 +8555,10 @@
             <a:prstDash val="solid"/>
           </a:ln>
         </p:spPr>
+        <p:txBody>
+          <a:bodyPr/>
+          <a:p/>
+        </p:txBody>
       </p:sp>
       <p:sp>
         <p:nvSpPr>
@@ -8701,6 +8928,10 @@
             <a:prstDash val="solid"/>
           </a:ln>
         </p:spPr>
+        <p:txBody>
+          <a:bodyPr/>
+          <a:p/>
+        </p:txBody>
       </p:sp>
       <p:sp>
         <p:nvSpPr>
@@ -8732,6 +8963,10 @@
             <a:prstDash val="solid"/>
           </a:ln>
         </p:spPr>
+        <p:txBody>
+          <a:bodyPr/>
+          <a:p/>
+        </p:txBody>
       </p:sp>
       <p:sp>
         <p:nvSpPr>
@@ -8813,6 +9048,10 @@
             <a:prstDash val="solid"/>
           </a:ln>
         </p:spPr>
+        <p:txBody>
+          <a:bodyPr/>
+          <a:p/>
+        </p:txBody>
       </p:sp>
       <p:sp>
         <p:nvSpPr>
@@ -8894,6 +9133,10 @@
             <a:prstDash val="solid"/>
           </a:ln>
         </p:spPr>
+        <p:txBody>
+          <a:bodyPr/>
+          <a:p/>
+        </p:txBody>
       </p:sp>
       <p:sp>
         <p:nvSpPr>
@@ -8975,6 +9218,10 @@
             <a:prstDash val="solid"/>
           </a:ln>
         </p:spPr>
+        <p:txBody>
+          <a:bodyPr/>
+          <a:p/>
+        </p:txBody>
       </p:sp>
       <p:sp>
         <p:nvSpPr>
@@ -9056,6 +9303,10 @@
             <a:prstDash val="solid"/>
           </a:ln>
         </p:spPr>
+        <p:txBody>
+          <a:bodyPr/>
+          <a:p/>
+        </p:txBody>
       </p:sp>
       <p:sp>
         <p:nvSpPr>
@@ -9139,6 +9390,10 @@
             <a:prstDash val="solid"/>
           </a:ln>
         </p:spPr>
+        <p:txBody>
+          <a:bodyPr/>
+          <a:p/>
+        </p:txBody>
       </p:sp>
       <p:sp>
         <p:nvSpPr>
@@ -9239,6 +9494,10 @@
             <a:prstDash val="solid"/>
           </a:ln>
         </p:spPr>
+        <p:txBody>
+          <a:bodyPr/>
+          <a:p/>
+        </p:txBody>
       </p:sp>
       <p:sp>
         <p:nvSpPr>
@@ -9339,6 +9598,10 @@
             <a:prstDash val="solid"/>
           </a:ln>
         </p:spPr>
+        <p:txBody>
+          <a:bodyPr/>
+          <a:p/>
+        </p:txBody>
       </p:sp>
       <p:sp>
         <p:nvSpPr>
@@ -9422,6 +9685,10 @@
             <a:prstDash val="solid"/>
           </a:ln>
         </p:spPr>
+        <p:txBody>
+          <a:bodyPr/>
+          <a:p/>
+        </p:txBody>
       </p:sp>
       <p:sp>
         <p:nvSpPr>
@@ -9505,6 +9772,10 @@
             <a:prstDash val="solid"/>
           </a:ln>
         </p:spPr>
+        <p:txBody>
+          <a:bodyPr/>
+          <a:p/>
+        </p:txBody>
       </p:sp>
       <p:sp>
         <p:nvSpPr>
@@ -9588,6 +9859,10 @@
             <a:prstDash val="solid"/>
           </a:ln>
         </p:spPr>
+        <p:txBody>
+          <a:bodyPr/>
+          <a:p/>
+        </p:txBody>
       </p:sp>
       <p:sp>
         <p:nvSpPr>
@@ -9688,6 +9963,10 @@
             <a:prstDash val="solid"/>
           </a:ln>
         </p:spPr>
+        <p:txBody>
+          <a:bodyPr/>
+          <a:p/>
+        </p:txBody>
       </p:sp>
       <p:sp>
         <p:nvSpPr>
@@ -9788,6 +10067,10 @@
             <a:prstDash val="solid"/>
           </a:ln>
         </p:spPr>
+        <p:txBody>
+          <a:bodyPr/>
+          <a:p/>
+        </p:txBody>
       </p:sp>
       <p:sp>
         <p:nvSpPr>
@@ -9888,6 +10171,10 @@
             <a:prstDash val="solid"/>
           </a:ln>
         </p:spPr>
+        <p:txBody>
+          <a:bodyPr/>
+          <a:p/>
+        </p:txBody>
       </p:sp>
       <p:sp>
         <p:nvSpPr>
@@ -9971,6 +10258,10 @@
             <a:prstDash val="solid"/>
           </a:ln>
         </p:spPr>
+        <p:txBody>
+          <a:bodyPr/>
+          <a:p/>
+        </p:txBody>
       </p:sp>
       <p:sp>
         <p:nvSpPr>
@@ -10054,6 +10345,10 @@
             <a:prstDash val="solid"/>
           </a:ln>
         </p:spPr>
+        <p:txBody>
+          <a:bodyPr/>
+          <a:p/>
+        </p:txBody>
       </p:sp>
       <p:sp>
         <p:nvSpPr>
@@ -10154,6 +10449,10 @@
             <a:prstDash val="solid"/>
           </a:ln>
         </p:spPr>
+        <p:txBody>
+          <a:bodyPr/>
+          <a:p/>
+        </p:txBody>
       </p:sp>
       <p:sp>
         <p:nvSpPr>
@@ -10254,6 +10553,10 @@
             <a:prstDash val="solid"/>
           </a:ln>
         </p:spPr>
+        <p:txBody>
+          <a:bodyPr/>
+          <a:p/>
+        </p:txBody>
       </p:sp>
       <p:sp>
         <p:nvSpPr>
@@ -10354,6 +10657,10 @@
             <a:prstDash val="solid"/>
           </a:ln>
         </p:spPr>
+        <p:txBody>
+          <a:bodyPr/>
+          <a:p/>
+        </p:txBody>
       </p:sp>
       <p:sp>
         <p:nvSpPr>
@@ -10437,6 +10744,10 @@
             <a:prstDash val="solid"/>
           </a:ln>
         </p:spPr>
+        <p:txBody>
+          <a:bodyPr/>
+          <a:p/>
+        </p:txBody>
       </p:sp>
       <p:sp>
         <p:nvSpPr>
@@ -10520,6 +10831,10 @@
             <a:prstDash val="solid"/>
           </a:ln>
         </p:spPr>
+        <p:txBody>
+          <a:bodyPr/>
+          <a:p/>
+        </p:txBody>
       </p:sp>
       <p:sp>
         <p:nvSpPr>
@@ -10620,6 +10935,10 @@
             <a:prstDash val="solid"/>
           </a:ln>
         </p:spPr>
+        <p:txBody>
+          <a:bodyPr/>
+          <a:p/>
+        </p:txBody>
       </p:sp>
       <p:sp>
         <p:nvSpPr>
@@ -10720,6 +11039,10 @@
             <a:prstDash val="solid"/>
           </a:ln>
         </p:spPr>
+        <p:txBody>
+          <a:bodyPr/>
+          <a:p/>
+        </p:txBody>
       </p:sp>
       <p:sp>
         <p:nvSpPr>
@@ -10820,6 +11143,10 @@
             <a:prstDash val="solid"/>
           </a:ln>
         </p:spPr>
+        <p:txBody>
+          <a:bodyPr/>
+          <a:p/>
+        </p:txBody>
       </p:sp>
       <p:sp>
         <p:nvSpPr>
@@ -10903,6 +11230,10 @@
             <a:prstDash val="solid"/>
           </a:ln>
         </p:spPr>
+        <p:txBody>
+          <a:bodyPr/>
+          <a:p/>
+        </p:txBody>
       </p:sp>
       <p:sp>
         <p:nvSpPr>
@@ -10986,6 +11317,10 @@
             <a:prstDash val="solid"/>
           </a:ln>
         </p:spPr>
+        <p:txBody>
+          <a:bodyPr/>
+          <a:p/>
+        </p:txBody>
       </p:sp>
       <p:sp>
         <p:nvSpPr>
@@ -11355,6 +11690,10 @@
             <a:prstDash val="solid"/>
           </a:ln>
         </p:spPr>
+        <p:txBody>
+          <a:bodyPr/>
+          <a:p/>
+        </p:txBody>
       </p:sp>
       <p:sp>
         <p:nvSpPr>
@@ -11386,6 +11725,10 @@
             <a:prstDash val="solid"/>
           </a:ln>
         </p:spPr>
+        <p:txBody>
+          <a:bodyPr/>
+          <a:p/>
+        </p:txBody>
       </p:sp>
       <p:sp>
         <p:nvSpPr>
@@ -11467,6 +11810,10 @@
             <a:prstDash val="solid"/>
           </a:ln>
         </p:spPr>
+        <p:txBody>
+          <a:bodyPr/>
+          <a:p/>
+        </p:txBody>
       </p:sp>
       <p:sp>
         <p:nvSpPr>
@@ -11548,6 +11895,10 @@
             <a:prstDash val="solid"/>
           </a:ln>
         </p:spPr>
+        <p:txBody>
+          <a:bodyPr/>
+          <a:p/>
+        </p:txBody>
       </p:sp>
       <p:sp>
         <p:nvSpPr>
@@ -11629,6 +11980,10 @@
             <a:prstDash val="solid"/>
           </a:ln>
         </p:spPr>
+        <p:txBody>
+          <a:bodyPr/>
+          <a:p/>
+        </p:txBody>
       </p:sp>
       <p:sp>
         <p:nvSpPr>
@@ -11710,6 +12065,10 @@
             <a:prstDash val="solid"/>
           </a:ln>
         </p:spPr>
+        <p:txBody>
+          <a:bodyPr/>
+          <a:p/>
+        </p:txBody>
       </p:sp>
       <p:sp>
         <p:nvSpPr>
@@ -11793,6 +12152,10 @@
             <a:prstDash val="solid"/>
           </a:ln>
         </p:spPr>
+        <p:txBody>
+          <a:bodyPr/>
+          <a:p/>
+        </p:txBody>
       </p:sp>
       <p:sp>
         <p:nvSpPr>
@@ -11893,6 +12256,10 @@
             <a:prstDash val="solid"/>
           </a:ln>
         </p:spPr>
+        <p:txBody>
+          <a:bodyPr/>
+          <a:p/>
+        </p:txBody>
       </p:sp>
       <p:sp>
         <p:nvSpPr>
@@ -11976,6 +12343,10 @@
             <a:prstDash val="solid"/>
           </a:ln>
         </p:spPr>
+        <p:txBody>
+          <a:bodyPr/>
+          <a:p/>
+        </p:txBody>
       </p:sp>
       <p:sp>
         <p:nvSpPr>
@@ -12059,6 +12430,10 @@
             <a:prstDash val="solid"/>
           </a:ln>
         </p:spPr>
+        <p:txBody>
+          <a:bodyPr/>
+          <a:p/>
+        </p:txBody>
       </p:sp>
       <p:sp>
         <p:nvSpPr>
@@ -12142,6 +12517,10 @@
             <a:prstDash val="solid"/>
           </a:ln>
         </p:spPr>
+        <p:txBody>
+          <a:bodyPr/>
+          <a:p/>
+        </p:txBody>
       </p:sp>
       <p:sp>
         <p:nvSpPr>
@@ -12225,6 +12604,10 @@
             <a:prstDash val="solid"/>
           </a:ln>
         </p:spPr>
+        <p:txBody>
+          <a:bodyPr/>
+          <a:p/>
+        </p:txBody>
       </p:sp>
       <p:sp>
         <p:nvSpPr>
@@ -12325,6 +12708,10 @@
             <a:prstDash val="solid"/>
           </a:ln>
         </p:spPr>
+        <p:txBody>
+          <a:bodyPr/>
+          <a:p/>
+        </p:txBody>
       </p:sp>
       <p:sp>
         <p:nvSpPr>
@@ -12408,6 +12795,10 @@
             <a:prstDash val="solid"/>
           </a:ln>
         </p:spPr>
+        <p:txBody>
+          <a:bodyPr/>
+          <a:p/>
+        </p:txBody>
       </p:sp>
       <p:sp>
         <p:nvSpPr>
@@ -12491,6 +12882,10 @@
             <a:prstDash val="solid"/>
           </a:ln>
         </p:spPr>
+        <p:txBody>
+          <a:bodyPr/>
+          <a:p/>
+        </p:txBody>
       </p:sp>
       <p:sp>
         <p:nvSpPr>
@@ -12574,6 +12969,10 @@
             <a:prstDash val="solid"/>
           </a:ln>
         </p:spPr>
+        <p:txBody>
+          <a:bodyPr/>
+          <a:p/>
+        </p:txBody>
       </p:sp>
       <p:sp>
         <p:nvSpPr>
@@ -12657,6 +13056,10 @@
             <a:prstDash val="solid"/>
           </a:ln>
         </p:spPr>
+        <p:txBody>
+          <a:bodyPr/>
+          <a:p/>
+        </p:txBody>
       </p:sp>
       <p:sp>
         <p:nvSpPr>
@@ -12757,6 +13160,10 @@
             <a:prstDash val="solid"/>
           </a:ln>
         </p:spPr>
+        <p:txBody>
+          <a:bodyPr/>
+          <a:p/>
+        </p:txBody>
       </p:sp>
       <p:sp>
         <p:nvSpPr>
@@ -12840,6 +13247,10 @@
             <a:prstDash val="solid"/>
           </a:ln>
         </p:spPr>
+        <p:txBody>
+          <a:bodyPr/>
+          <a:p/>
+        </p:txBody>
       </p:sp>
       <p:sp>
         <p:nvSpPr>
@@ -12923,6 +13334,10 @@
             <a:prstDash val="solid"/>
           </a:ln>
         </p:spPr>
+        <p:txBody>
+          <a:bodyPr/>
+          <a:p/>
+        </p:txBody>
       </p:sp>
       <p:sp>
         <p:nvSpPr>
@@ -13006,6 +13421,10 @@
             <a:prstDash val="solid"/>
           </a:ln>
         </p:spPr>
+        <p:txBody>
+          <a:bodyPr/>
+          <a:p/>
+        </p:txBody>
       </p:sp>
       <p:sp>
         <p:nvSpPr>
@@ -13089,6 +13508,10 @@
             <a:prstDash val="solid"/>
           </a:ln>
         </p:spPr>
+        <p:txBody>
+          <a:bodyPr/>
+          <a:p/>
+        </p:txBody>
       </p:sp>
       <p:sp>
         <p:nvSpPr>
@@ -13189,6 +13612,10 @@
             <a:prstDash val="solid"/>
           </a:ln>
         </p:spPr>
+        <p:txBody>
+          <a:bodyPr/>
+          <a:p/>
+        </p:txBody>
       </p:sp>
       <p:sp>
         <p:nvSpPr>
@@ -13272,6 +13699,10 @@
             <a:prstDash val="solid"/>
           </a:ln>
         </p:spPr>
+        <p:txBody>
+          <a:bodyPr/>
+          <a:p/>
+        </p:txBody>
       </p:sp>
       <p:sp>
         <p:nvSpPr>
@@ -13355,6 +13786,10 @@
             <a:prstDash val="solid"/>
           </a:ln>
         </p:spPr>
+        <p:txBody>
+          <a:bodyPr/>
+          <a:p/>
+        </p:txBody>
       </p:sp>
       <p:sp>
         <p:nvSpPr>
@@ -13438,6 +13873,10 @@
             <a:prstDash val="solid"/>
           </a:ln>
         </p:spPr>
+        <p:txBody>
+          <a:bodyPr/>
+          <a:p/>
+        </p:txBody>
       </p:sp>
       <p:sp>
         <p:nvSpPr>
@@ -13571,6 +14010,10 @@
             <a:prstDash val="solid"/>
           </a:ln>
         </p:spPr>
+        <p:txBody>
+          <a:bodyPr/>
+          <a:p/>
+        </p:txBody>
       </p:sp>
       <p:sp>
         <p:nvSpPr>
@@ -13654,6 +14097,10 @@
             <a:prstDash val="solid"/>
           </a:ln>
         </p:spPr>
+        <p:txBody>
+          <a:bodyPr/>
+          <a:p/>
+        </p:txBody>
       </p:sp>
       <p:sp>
         <p:nvSpPr>
@@ -13737,6 +14184,10 @@
             <a:prstDash val="solid"/>
           </a:ln>
         </p:spPr>
+        <p:txBody>
+          <a:bodyPr/>
+          <a:p/>
+        </p:txBody>
       </p:sp>
       <p:sp>
         <p:nvSpPr>
@@ -13820,6 +14271,10 @@
             <a:prstDash val="solid"/>
           </a:ln>
         </p:spPr>
+        <p:txBody>
+          <a:bodyPr/>
+          <a:p/>
+        </p:txBody>
       </p:sp>
       <p:sp>
         <p:nvSpPr>
@@ -14189,6 +14644,10 @@
             <a:prstDash val="solid"/>
           </a:ln>
         </p:spPr>
+        <p:txBody>
+          <a:bodyPr/>
+          <a:p/>
+        </p:txBody>
       </p:sp>
       <p:sp>
         <p:nvSpPr>
@@ -14224,6 +14683,10 @@
             <a:prstDash val="solid"/>
           </a:ln>
         </p:spPr>
+        <p:txBody>
+          <a:bodyPr/>
+          <a:p/>
+        </p:txBody>
       </p:sp>
       <p:sp>
         <p:nvSpPr>
@@ -14255,6 +14718,10 @@
             <a:prstDash val="solid"/>
           </a:ln>
         </p:spPr>
+        <p:txBody>
+          <a:bodyPr/>
+          <a:p/>
+        </p:txBody>
       </p:sp>
       <p:sp>
         <p:nvSpPr>
@@ -14907,6 +15374,10 @@
             <a:prstDash val="solid"/>
           </a:ln>
         </p:spPr>
+        <p:txBody>
+          <a:bodyPr/>
+          <a:p/>
+        </p:txBody>
       </p:sp>
       <p:sp>
         <p:nvSpPr>
@@ -14938,6 +15409,10 @@
             <a:prstDash val="solid"/>
           </a:ln>
         </p:spPr>
+        <p:txBody>
+          <a:bodyPr/>
+          <a:p/>
+        </p:txBody>
       </p:sp>
       <p:sp>
         <p:nvSpPr>
@@ -15590,6 +16065,10 @@
             <a:prstDash val="solid"/>
           </a:ln>
         </p:spPr>
+        <p:txBody>
+          <a:bodyPr/>
+          <a:p/>
+        </p:txBody>
       </p:sp>
       <p:sp>
         <p:nvSpPr>
@@ -15621,6 +16100,10 @@
             <a:prstDash val="solid"/>
           </a:ln>
         </p:spPr>
+        <p:txBody>
+          <a:bodyPr/>
+          <a:p/>
+        </p:txBody>
       </p:sp>
       <p:sp>
         <p:nvSpPr>
@@ -16607,6 +17090,10 @@
             <a:prstDash val="solid"/>
           </a:ln>
         </p:spPr>
+        <p:txBody>
+          <a:bodyPr/>
+          <a:p/>
+        </p:txBody>
       </p:sp>
       <p:sp>
         <p:nvSpPr>
@@ -17142,6 +17629,10 @@
             <a:prstDash val="solid"/>
           </a:ln>
         </p:spPr>
+        <p:txBody>
+          <a:bodyPr/>
+          <a:p/>
+        </p:txBody>
       </p:sp>
       <p:sp>
         <p:nvSpPr>
@@ -17172,6 +17663,10 @@
             <a:prstDash val="solid"/>
           </a:ln>
         </p:spPr>
+        <p:txBody>
+          <a:bodyPr/>
+          <a:p/>
+        </p:txBody>
       </p:sp>
       <p:sp>
         <p:nvSpPr>
@@ -17257,6 +17752,10 @@
             <a:prstDash val="solid"/>
           </a:ln>
         </p:spPr>
+        <p:txBody>
+          <a:bodyPr/>
+          <a:p/>
+        </p:txBody>
       </p:sp>
       <p:sp>
         <p:nvSpPr>
@@ -17287,6 +17786,10 @@
             <a:prstDash val="solid"/>
           </a:ln>
         </p:spPr>
+        <p:txBody>
+          <a:bodyPr/>
+          <a:p/>
+        </p:txBody>
       </p:sp>
       <p:sp>
         <p:nvSpPr>
@@ -17389,6 +17892,10 @@
             <a:prstDash val="solid"/>
           </a:ln>
         </p:spPr>
+        <p:txBody>
+          <a:bodyPr/>
+          <a:p/>
+        </p:txBody>
       </p:sp>
       <p:sp>
         <p:nvSpPr>
@@ -17419,6 +17926,10 @@
             <a:prstDash val="solid"/>
           </a:ln>
         </p:spPr>
+        <p:txBody>
+          <a:bodyPr/>
+          <a:p/>
+        </p:txBody>
       </p:sp>
       <p:sp>
         <p:nvSpPr>
@@ -17521,6 +18032,10 @@
             <a:prstDash val="solid"/>
           </a:ln>
         </p:spPr>
+        <p:txBody>
+          <a:bodyPr/>
+          <a:p/>
+        </p:txBody>
       </p:sp>
       <p:sp>
         <p:nvSpPr>
@@ -17551,6 +18066,10 @@
             <a:prstDash val="solid"/>
           </a:ln>
         </p:spPr>
+        <p:txBody>
+          <a:bodyPr/>
+          <a:p/>
+        </p:txBody>
       </p:sp>
       <p:sp>
         <p:nvSpPr>
@@ -17653,6 +18172,10 @@
             <a:prstDash val="solid"/>
           </a:ln>
         </p:spPr>
+        <p:txBody>
+          <a:bodyPr/>
+          <a:p/>
+        </p:txBody>
       </p:sp>
       <p:sp>
         <p:nvSpPr>
@@ -17683,6 +18206,10 @@
             <a:prstDash val="solid"/>
           </a:ln>
         </p:spPr>
+        <p:txBody>
+          <a:bodyPr/>
+          <a:p/>
+        </p:txBody>
       </p:sp>
       <p:sp>
         <p:nvSpPr>
@@ -17785,6 +18312,10 @@
             <a:prstDash val="solid"/>
           </a:ln>
         </p:spPr>
+        <p:txBody>
+          <a:bodyPr/>
+          <a:p/>
+        </p:txBody>
       </p:sp>
       <p:sp>
         <p:nvSpPr>
@@ -17815,6 +18346,10 @@
             <a:prstDash val="solid"/>
           </a:ln>
         </p:spPr>
+        <p:txBody>
+          <a:bodyPr/>
+          <a:p/>
+        </p:txBody>
       </p:sp>
       <p:sp>
         <p:nvSpPr>
@@ -17900,6 +18435,10 @@
             <a:prstDash val="solid"/>
           </a:ln>
         </p:spPr>
+        <p:txBody>
+          <a:bodyPr/>
+          <a:p/>
+        </p:txBody>
       </p:sp>
       <p:sp>
         <p:nvSpPr>
@@ -17930,6 +18469,10 @@
             <a:prstDash val="solid"/>
           </a:ln>
         </p:spPr>
+        <p:txBody>
+          <a:bodyPr/>
+          <a:p/>
+        </p:txBody>
       </p:sp>
       <p:sp>
         <p:nvSpPr>
@@ -18032,6 +18575,10 @@
             <a:prstDash val="solid"/>
           </a:ln>
         </p:spPr>
+        <p:txBody>
+          <a:bodyPr/>
+          <a:p/>
+        </p:txBody>
       </p:sp>
       <p:sp>
         <p:nvSpPr>
@@ -18062,6 +18609,10 @@
             <a:prstDash val="solid"/>
           </a:ln>
         </p:spPr>
+        <p:txBody>
+          <a:bodyPr/>
+          <a:p/>
+        </p:txBody>
       </p:sp>
       <p:sp>
         <p:nvSpPr>
@@ -18147,6 +18698,10 @@
             <a:prstDash val="solid"/>
           </a:ln>
         </p:spPr>
+        <p:txBody>
+          <a:bodyPr/>
+          <a:p/>
+        </p:txBody>
       </p:sp>
       <p:sp>
         <p:nvSpPr>
@@ -18177,6 +18732,10 @@
             <a:prstDash val="solid"/>
           </a:ln>
         </p:spPr>
+        <p:txBody>
+          <a:bodyPr/>
+          <a:p/>
+        </p:txBody>
       </p:sp>
       <p:sp>
         <p:nvSpPr>
@@ -18279,6 +18838,10 @@
             <a:prstDash val="solid"/>
           </a:ln>
         </p:spPr>
+        <p:txBody>
+          <a:bodyPr/>
+          <a:p/>
+        </p:txBody>
       </p:sp>
       <p:sp>
         <p:nvSpPr>
@@ -18362,6 +18925,10 @@
             <a:prstDash val="solid"/>
           </a:ln>
         </p:spPr>
+        <p:txBody>
+          <a:bodyPr/>
+          <a:p/>
+        </p:txBody>
       </p:sp>
       <p:sp>
         <p:nvSpPr>
@@ -18445,6 +19012,10 @@
             <a:prstDash val="solid"/>
           </a:ln>
         </p:spPr>
+        <p:txBody>
+          <a:bodyPr/>
+          <a:p/>
+        </p:txBody>
       </p:sp>
       <p:sp>
         <p:nvSpPr>
@@ -18528,6 +19099,10 @@
             <a:prstDash val="solid"/>
           </a:ln>
         </p:spPr>
+        <p:txBody>
+          <a:bodyPr/>
+          <a:p/>
+        </p:txBody>
       </p:sp>
       <p:sp>
         <p:nvSpPr>
@@ -18611,6 +19186,10 @@
             <a:prstDash val="solid"/>
           </a:ln>
         </p:spPr>
+        <p:txBody>
+          <a:bodyPr/>
+          <a:p/>
+        </p:txBody>
       </p:sp>
       <p:sp>
         <p:nvSpPr>
@@ -18694,6 +19273,10 @@
             <a:prstDash val="solid"/>
           </a:ln>
         </p:spPr>
+        <p:txBody>
+          <a:bodyPr/>
+          <a:p/>
+        </p:txBody>
       </p:sp>
       <p:sp>
         <p:nvSpPr>
@@ -19113,6 +19696,10 @@
             <a:prstDash val="solid"/>
           </a:ln>
         </p:spPr>
+        <p:txBody>
+          <a:bodyPr/>
+          <a:p/>
+        </p:txBody>
       </p:sp>
       <p:sp>
         <p:nvSpPr>
@@ -19148,6 +19735,10 @@
             <a:prstDash val="solid"/>
           </a:ln>
         </p:spPr>
+        <p:txBody>
+          <a:bodyPr/>
+          <a:p/>
+        </p:txBody>
       </p:sp>
       <p:sp>
         <p:nvSpPr>
@@ -19233,6 +19824,10 @@
             <a:prstDash val="solid"/>
           </a:ln>
         </p:spPr>
+        <p:txBody>
+          <a:bodyPr/>
+          <a:p/>
+        </p:txBody>
       </p:sp>
       <p:sp>
         <p:nvSpPr>
@@ -19318,6 +19913,10 @@
             <a:prstDash val="solid"/>
           </a:ln>
         </p:spPr>
+        <p:txBody>
+          <a:bodyPr/>
+          <a:p/>
+        </p:txBody>
       </p:sp>
       <p:sp>
         <p:nvSpPr>
@@ -19403,6 +20002,10 @@
             <a:prstDash val="solid"/>
           </a:ln>
         </p:spPr>
+        <p:txBody>
+          <a:bodyPr/>
+          <a:p/>
+        </p:txBody>
       </p:sp>
       <p:sp>
         <p:nvSpPr>
@@ -19488,6 +20091,10 @@
             <a:prstDash val="solid"/>
           </a:ln>
         </p:spPr>
+        <p:txBody>
+          <a:bodyPr/>
+          <a:p/>
+        </p:txBody>
       </p:sp>
       <p:sp>
         <p:nvSpPr>
@@ -19573,6 +20180,10 @@
             <a:prstDash val="solid"/>
           </a:ln>
         </p:spPr>
+        <p:txBody>
+          <a:bodyPr/>
+          <a:p/>
+        </p:txBody>
       </p:sp>
       <p:sp>
         <p:nvSpPr>
@@ -19658,6 +20269,10 @@
             <a:prstDash val="solid"/>
           </a:ln>
         </p:spPr>
+        <p:txBody>
+          <a:bodyPr/>
+          <a:p/>
+        </p:txBody>
       </p:sp>
       <p:sp>
         <p:nvSpPr>
@@ -19743,6 +20358,10 @@
             <a:prstDash val="solid"/>
           </a:ln>
         </p:spPr>
+        <p:txBody>
+          <a:bodyPr/>
+          <a:p/>
+        </p:txBody>
       </p:sp>
       <p:sp>
         <p:nvSpPr>

</xml_diff>